<commit_message>
Link slide videos to the Google Drive copies
Co-Authored-By: Claude Opus 5.5 <noreply@anthropic.com>
</commit_message>
<xml_diff>
--- a/logs/scoop_traj_search/robomaster_lacrosse_scoop_progress_v2.pptx
+++ b/logs/scoop_traj_search/robomaster_lacrosse_scoop_progress_v2.pptx
@@ -124,20 +124,20 @@
   <p:extLst>
     <p:ext uri="{521415D9-36F7-43E2-AB2F-B90AF26B5E84}">
       <p14:sectionLst xmlns:p14="http://schemas.microsoft.com/office/powerpoint/2010/main">
-        <p14:section name="Intro" id="{50424d13-be5d-caa9-0b51-305aa1f60fb0}">
+        <p14:section name="Intro" id="{e99302c5-83b7-c263-b257-5edcd9d75e10}">
           <p14:sldIdLst>
             <p14:sldId id="256"/>
             <p14:sldId id="257"/>
           </p14:sldIdLst>
         </p14:section>
-        <p14:section name="Setup" id="{53959e29-77a1-64d0-704b-cb4cf8a710a5}">
+        <p14:section name="Setup" id="{24c1d65a-6058-c906-c994-a1f3cb75a704}">
           <p14:sldIdLst>
             <p14:sldId id="258"/>
             <p14:sldId id="259"/>
             <p14:sldId id="260"/>
           </p14:sldIdLst>
         </p14:section>
-        <p14:section name="Method" id="{cf8af466-1084-e1ae-d04e-3af3ed38371f}">
+        <p14:section name="Method" id="{60f0d943-ede9-f4df-c98b-2da620a29e14}">
           <p14:sldIdLst>
             <p14:sldId id="261"/>
             <p14:sldId id="262"/>
@@ -145,7 +145,7 @@
             <p14:sldId id="264"/>
           </p14:sldIdLst>
         </p14:section>
-        <p14:section name="Results" id="{a650af67-067a-b3be-8ee6-9359400d4e40}">
+        <p14:section name="Results" id="{0bf03d58-2f4e-0959-ae0d-0861e943884e}">
           <p14:sldIdLst>
             <p14:sldId id="265"/>
             <p14:sldId id="266"/>
@@ -154,14 +154,14 @@
             <p14:sldId id="269"/>
           </p14:sldIdLst>
         </p14:section>
-        <p14:section name="Torque" id="{56f373c8-a01a-0f3b-0174-c3ead919c3ee}">
+        <p14:section name="Torque" id="{50cedef7-2009-68f4-ca30-86a00f7256f1}">
           <p14:sldIdLst>
             <p14:sldId id="270"/>
             <p14:sldId id="271"/>
             <p14:sldId id="272"/>
           </p14:sldIdLst>
         </p14:section>
-        <p14:section name="Next" id="{7949e14b-62ab-870d-e54a-b93aef7dcbf9}">
+        <p14:section name="Next" id="{2c492ff2-6e56-73e5-8fbc-dec0a3e9b4fa}">
           <p14:sldIdLst>
             <p14:sldId id="273"/>
           </p14:sldIdLst>
@@ -4507,7 +4507,9 @@
       </p:sp>
       <p:pic>
         <p:nvPicPr>
-          <p:cNvPr id="4" name="video-wheels_slow" descr="/tmp/claude-1000/-home-yifan-IsaacLab/02e1a1d7-61f9-5921-a435-b68e19ec6560/scratchpad/deck/img/vid/wheels_slow.jpg">    </p:cNvPr>
+          <p:cNvPr id="4" name="video-wheels_slow" descr="/tmp/claude-1000/-home-yifan-IsaacLab/02e1a1d7-61f9-5921-a435-b68e19ec6560/scratchpad/deck/img/vid/wheels_slow.jpg">
+            <a:hlinkClick r:id="rId2" tooltip="Open video on Google Drive"/>
+          </p:cNvPr>
           <p:cNvPicPr>
             <a:picLocks noChangeAspect="1"/>
           </p:cNvPicPr>
@@ -4531,7 +4533,9 @@
       </p:pic>
       <p:sp>
         <p:nvSpPr>
-          <p:cNvPr id="5" name="Shape 2"/>
+          <p:cNvPr id="5" name="Shape 2">
+            <a:hlinkClick r:id="rId3" tooltip=""/>
+          </p:cNvPr>
           <p:cNvSpPr/>
           <p:nvPr/>
         </p:nvSpPr>
@@ -4615,12 +4619,19 @@
               <a:buNone/>
             </a:pPr>
             <a:r>
-              <a:rPr lang="en-US" sz="1200" i="1" dirty="0">
-                <a:solidFill>
-                  <a:schemeClr val="accent6"/>
-                </a:solidFill>
-              </a:rPr>
-              <a:t>Google Drive link: to be added (12 s)</a:t>
+              <a:rPr lang="en-US" sz="1200" u="sng" dirty="0">
+                <a:solidFill>
+                  <a:schemeClr val="accent4"/>
+                </a:solidFill>
+                <a:hlinkClick r:id="rId4" invalidUrl="" action="" tgtFrame="" tooltip="" history="1" highlightClick="0" endSnd="0">
+                  <a:extLst>
+                    <a:ext uri="{A12FA001-AC4F-418D-AE19-62706E023703}">
+                      <ahyp:hlinkClr xmlns:ahyp="http://schemas.microsoft.com/office/drawing/2018/hyperlinkcolor" val="tx"/>
+                    </a:ext>
+                  </a:extLst>
+                </a:hlinkClick>
+              </a:rPr>
+              <a:t>▶ Watch on Google Drive (12 s)</a:t>
             </a:r>
             <a:endParaRPr lang="en-US" sz="1200" dirty="0"/>
           </a:p>
@@ -5635,7 +5646,9 @@
       </p:sp>
       <p:pic>
         <p:nvPicPr>
-          <p:cNvPr id="3" name="video-array" descr="/tmp/claude-1000/-home-yifan-IsaacLab/02e1a1d7-61f9-5921-a435-b68e19ec6560/scratchpad/deck/img/vid/array.jpg">    </p:cNvPr>
+          <p:cNvPr id="3" name="video-array" descr="/tmp/claude-1000/-home-yifan-IsaacLab/02e1a1d7-61f9-5921-a435-b68e19ec6560/scratchpad/deck/img/vid/array.jpg">
+            <a:hlinkClick r:id="rId2" tooltip="Open video on Google Drive"/>
+          </p:cNvPr>
           <p:cNvPicPr>
             <a:picLocks noChangeAspect="1"/>
           </p:cNvPicPr>
@@ -5659,7 +5672,9 @@
       </p:pic>
       <p:sp>
         <p:nvSpPr>
-          <p:cNvPr id="4" name="Shape 1"/>
+          <p:cNvPr id="4" name="Shape 1">
+            <a:hlinkClick r:id="rId3" tooltip=""/>
+          </p:cNvPr>
           <p:cNvSpPr/>
           <p:nvPr/>
         </p:nvSpPr>
@@ -5743,12 +5758,19 @@
               <a:buNone/>
             </a:pPr>
             <a:r>
-              <a:rPr lang="en-US" sz="1200" i="1" dirty="0">
-                <a:solidFill>
-                  <a:schemeClr val="accent6"/>
-                </a:solidFill>
-              </a:rPr>
-              <a:t>Google Drive link: to be added (18 s)</a:t>
+              <a:rPr lang="en-US" sz="1200" u="sng" dirty="0">
+                <a:solidFill>
+                  <a:schemeClr val="accent4"/>
+                </a:solidFill>
+                <a:hlinkClick r:id="rId4" invalidUrl="" action="" tgtFrame="" tooltip="" history="1" highlightClick="0" endSnd="0">
+                  <a:extLst>
+                    <a:ext uri="{A12FA001-AC4F-418D-AE19-62706E023703}">
+                      <ahyp:hlinkClr xmlns:ahyp="http://schemas.microsoft.com/office/drawing/2018/hyperlinkcolor" val="tx"/>
+                    </a:ext>
+                  </a:extLst>
+                </a:hlinkClick>
+              </a:rPr>
+              <a:t>▶ Watch on Google Drive (18 s)</a:t>
             </a:r>
             <a:endParaRPr lang="en-US" sz="1200" dirty="0"/>
           </a:p>
@@ -6090,14 +6112,14 @@
               <a:buNone/>
             </a:pPr>
             <a:r>
-              <a:rPr lang="en-US" sz="1500" b="1" dirty="0">
+              <a:rPr lang="en-US" sz="1400" b="1" dirty="0">
                 <a:solidFill>
                   <a:schemeClr val="accent3"/>
                 </a:solidFill>
               </a:rPr>
               <a:t>A · Late contact: ball ~2 cm farther, slides off the lip</a:t>
             </a:r>
-            <a:endParaRPr lang="en-US" sz="1500" dirty="0"/>
+            <a:endParaRPr lang="en-US" sz="1400" dirty="0"/>
           </a:p>
         </p:txBody>
       </p:sp>
@@ -6126,20 +6148,22 @@
               <a:buNone/>
             </a:pPr>
             <a:r>
-              <a:rPr lang="en-US" sz="1500" b="1" dirty="0">
+              <a:rPr lang="en-US" sz="1400" b="1" dirty="0">
                 <a:solidFill>
                   <a:schemeClr val="accent5"/>
                 </a:solidFill>
               </a:rPr>
               <a:t>B · Lifted to ~43 cm, thrown out of the pocket side</a:t>
             </a:r>
-            <a:endParaRPr lang="en-US" sz="1500" dirty="0"/>
+            <a:endParaRPr lang="en-US" sz="1400" dirty="0"/>
           </a:p>
         </p:txBody>
       </p:sp>
       <p:pic>
         <p:nvPicPr>
-          <p:cNvPr id="5" name="video-f145x" descr="/tmp/claude-1000/-home-yifan-IsaacLab/02e1a1d7-61f9-5921-a435-b68e19ec6560/scratchpad/deck/img/vid/f145x.jpg">    </p:cNvPr>
+          <p:cNvPr id="5" name="video-f145x" descr="/tmp/claude-1000/-home-yifan-IsaacLab/02e1a1d7-61f9-5921-a435-b68e19ec6560/scratchpad/deck/img/vid/f145x.jpg">
+            <a:hlinkClick r:id="rId2" tooltip="Open video on Google Drive"/>
+          </p:cNvPr>
           <p:cNvPicPr>
             <a:picLocks noChangeAspect="1"/>
           </p:cNvPicPr>
@@ -6163,7 +6187,9 @@
       </p:pic>
       <p:sp>
         <p:nvSpPr>
-          <p:cNvPr id="6" name="Shape 3"/>
+          <p:cNvPr id="6" name="Shape 3">
+            <a:hlinkClick r:id="rId3" tooltip=""/>
+          </p:cNvPr>
           <p:cNvSpPr/>
           <p:nvPr/>
         </p:nvSpPr>
@@ -6247,12 +6273,19 @@
               <a:buNone/>
             </a:pPr>
             <a:r>
-              <a:rPr lang="en-US" sz="1200" i="1" dirty="0">
-                <a:solidFill>
-                  <a:schemeClr val="accent6"/>
-                </a:solidFill>
-              </a:rPr>
-              <a:t>Google Drive link: to be added (8 s)</a:t>
+              <a:rPr lang="en-US" sz="1200" u="sng" dirty="0">
+                <a:solidFill>
+                  <a:schemeClr val="accent4"/>
+                </a:solidFill>
+                <a:hlinkClick r:id="rId4" invalidUrl="" action="" tgtFrame="" tooltip="" history="1" highlightClick="0" endSnd="0">
+                  <a:extLst>
+                    <a:ext uri="{A12FA001-AC4F-418D-AE19-62706E023703}">
+                      <ahyp:hlinkClr xmlns:ahyp="http://schemas.microsoft.com/office/drawing/2018/hyperlinkcolor" val="tx"/>
+                    </a:ext>
+                  </a:extLst>
+                </a:hlinkClick>
+              </a:rPr>
+              <a:t>▶ Watch on Google Drive (8 s)</a:t>
             </a:r>
             <a:endParaRPr lang="en-US" sz="1200" dirty="0"/>
           </a:p>
@@ -6260,14 +6293,16 @@
       </p:sp>
       <p:pic>
         <p:nvPicPr>
-          <p:cNvPr id="9" name="video-f203x" descr="/tmp/claude-1000/-home-yifan-IsaacLab/02e1a1d7-61f9-5921-a435-b68e19ec6560/scratchpad/deck/img/vid/f203x.jpg">    </p:cNvPr>
+          <p:cNvPr id="9" name="video-f203x" descr="/tmp/claude-1000/-home-yifan-IsaacLab/02e1a1d7-61f9-5921-a435-b68e19ec6560/scratchpad/deck/img/vid/f203x.jpg">
+            <a:hlinkClick r:id="rId6" tooltip="Open video on Google Drive"/>
+          </p:cNvPr>
           <p:cNvPicPr>
             <a:picLocks noChangeAspect="1"/>
           </p:cNvPicPr>
           <p:nvPr/>
         </p:nvPicPr>
         <p:blipFill>
-          <a:blip r:embed="rId2"/>
+          <a:blip r:embed="rId5"/>
           <a:stretch>
             <a:fillRect/>
           </a:stretch>
@@ -6284,7 +6319,9 @@
       </p:pic>
       <p:sp>
         <p:nvSpPr>
-          <p:cNvPr id="10" name="Shape 6"/>
+          <p:cNvPr id="10" name="Shape 6">
+            <a:hlinkClick r:id="rId7" tooltip=""/>
+          </p:cNvPr>
           <p:cNvSpPr/>
           <p:nvPr/>
         </p:nvSpPr>
@@ -6368,12 +6405,19 @@
               <a:buNone/>
             </a:pPr>
             <a:r>
-              <a:rPr lang="en-US" sz="1200" i="1" dirty="0">
-                <a:solidFill>
-                  <a:schemeClr val="accent6"/>
-                </a:solidFill>
-              </a:rPr>
-              <a:t>Google Drive link: to be added (8 s)</a:t>
+              <a:rPr lang="en-US" sz="1200" u="sng" dirty="0">
+                <a:solidFill>
+                  <a:schemeClr val="accent4"/>
+                </a:solidFill>
+                <a:hlinkClick r:id="rId8" invalidUrl="" action="" tgtFrame="" tooltip="" history="1" highlightClick="0" endSnd="0">
+                  <a:extLst>
+                    <a:ext uri="{A12FA001-AC4F-418D-AE19-62706E023703}">
+                      <ahyp:hlinkClr xmlns:ahyp="http://schemas.microsoft.com/office/drawing/2018/hyperlinkcolor" val="tx"/>
+                    </a:ext>
+                  </a:extLst>
+                </a:hlinkClick>
+              </a:rPr>
+              <a:t>▶ Watch on Google Drive (8 s)</a:t>
             </a:r>
             <a:endParaRPr lang="en-US" sz="1200" dirty="0"/>
           </a:p>
@@ -6381,14 +6425,16 @@
       </p:sp>
       <p:pic>
         <p:nvPicPr>
-          <p:cNvPr id="13" name="video-f172x" descr="/tmp/claude-1000/-home-yifan-IsaacLab/02e1a1d7-61f9-5921-a435-b68e19ec6560/scratchpad/deck/img/vid/f172x.jpg">    </p:cNvPr>
+          <p:cNvPr id="13" name="video-f172x" descr="/tmp/claude-1000/-home-yifan-IsaacLab/02e1a1d7-61f9-5921-a435-b68e19ec6560/scratchpad/deck/img/vid/f172x.jpg">
+            <a:hlinkClick r:id="rId10" tooltip="Open video on Google Drive"/>
+          </p:cNvPr>
           <p:cNvPicPr>
             <a:picLocks noChangeAspect="1"/>
           </p:cNvPicPr>
           <p:nvPr/>
         </p:nvPicPr>
         <p:blipFill>
-          <a:blip r:embed="rId3"/>
+          <a:blip r:embed="rId9"/>
           <a:stretch>
             <a:fillRect/>
           </a:stretch>
@@ -6405,7 +6451,9 @@
       </p:pic>
       <p:sp>
         <p:nvSpPr>
-          <p:cNvPr id="14" name="Shape 9"/>
+          <p:cNvPr id="14" name="Shape 9">
+            <a:hlinkClick r:id="rId11" tooltip=""/>
+          </p:cNvPr>
           <p:cNvSpPr/>
           <p:nvPr/>
         </p:nvSpPr>
@@ -6489,12 +6537,19 @@
               <a:buNone/>
             </a:pPr>
             <a:r>
-              <a:rPr lang="en-US" sz="1200" i="1" dirty="0">
-                <a:solidFill>
-                  <a:schemeClr val="accent6"/>
-                </a:solidFill>
-              </a:rPr>
-              <a:t>Google Drive link: to be added (8 s)</a:t>
+              <a:rPr lang="en-US" sz="1200" u="sng" dirty="0">
+                <a:solidFill>
+                  <a:schemeClr val="accent4"/>
+                </a:solidFill>
+                <a:hlinkClick r:id="rId12" invalidUrl="" action="" tgtFrame="" tooltip="" history="1" highlightClick="0" endSnd="0">
+                  <a:extLst>
+                    <a:ext uri="{A12FA001-AC4F-418D-AE19-62706E023703}">
+                      <ahyp:hlinkClr xmlns:ahyp="http://schemas.microsoft.com/office/drawing/2018/hyperlinkcolor" val="tx"/>
+                    </a:ext>
+                  </a:extLst>
+                </a:hlinkClick>
+              </a:rPr>
+              <a:t>▶ Watch on Google Drive (8 s)</a:t>
             </a:r>
             <a:endParaRPr lang="en-US" sz="1200" dirty="0"/>
           </a:p>
@@ -6502,14 +6557,16 @@
       </p:sp>
       <p:pic>
         <p:nvPicPr>
-          <p:cNvPr id="17" name="video-f307x" descr="/tmp/claude-1000/-home-yifan-IsaacLab/02e1a1d7-61f9-5921-a435-b68e19ec6560/scratchpad/deck/img/vid/f307x.jpg">    </p:cNvPr>
+          <p:cNvPr id="17" name="video-f307x" descr="/tmp/claude-1000/-home-yifan-IsaacLab/02e1a1d7-61f9-5921-a435-b68e19ec6560/scratchpad/deck/img/vid/f307x.jpg">
+            <a:hlinkClick r:id="rId14" tooltip="Open video on Google Drive"/>
+          </p:cNvPr>
           <p:cNvPicPr>
             <a:picLocks noChangeAspect="1"/>
           </p:cNvPicPr>
           <p:nvPr/>
         </p:nvPicPr>
         <p:blipFill>
-          <a:blip r:embed="rId4"/>
+          <a:blip r:embed="rId13"/>
           <a:stretch>
             <a:fillRect/>
           </a:stretch>
@@ -6526,7 +6583,9 @@
       </p:pic>
       <p:sp>
         <p:nvSpPr>
-          <p:cNvPr id="18" name="Shape 12"/>
+          <p:cNvPr id="18" name="Shape 12">
+            <a:hlinkClick r:id="rId15" tooltip=""/>
+          </p:cNvPr>
           <p:cNvSpPr/>
           <p:nvPr/>
         </p:nvSpPr>
@@ -6610,12 +6669,19 @@
               <a:buNone/>
             </a:pPr>
             <a:r>
-              <a:rPr lang="en-US" sz="1200" i="1" dirty="0">
-                <a:solidFill>
-                  <a:schemeClr val="accent6"/>
-                </a:solidFill>
-              </a:rPr>
-              <a:t>Google Drive link: to be added (8 s)</a:t>
+              <a:rPr lang="en-US" sz="1200" u="sng" dirty="0">
+                <a:solidFill>
+                  <a:schemeClr val="accent4"/>
+                </a:solidFill>
+                <a:hlinkClick r:id="rId16" invalidUrl="" action="" tgtFrame="" tooltip="" history="1" highlightClick="0" endSnd="0">
+                  <a:extLst>
+                    <a:ext uri="{A12FA001-AC4F-418D-AE19-62706E023703}">
+                      <ahyp:hlinkClr xmlns:ahyp="http://schemas.microsoft.com/office/drawing/2018/hyperlinkcolor" val="tx"/>
+                    </a:ext>
+                  </a:extLst>
+                </a:hlinkClick>
+              </a:rPr>
+              <a:t>▶ Watch on Google Drive (8 s)</a:t>
             </a:r>
             <a:endParaRPr lang="en-US" sz="1200" dirty="0"/>
           </a:p>
@@ -9249,6 +9315,24 @@
               </a:rPr>
               <a:t>Code and results: github.com/emmmum/IsaacLab, branch yifan/robomaster-lacrosse-scoop</a:t>
             </a:r>
+            <a:pPr indent="0" marL="0">
+              <a:buNone/>
+            </a:pPr>
+            <a:r>
+              <a:rPr lang="en-US" sz="1100" i="1" u="sng" dirty="0">
+                <a:solidFill>
+                  <a:schemeClr val="accent1"/>
+                </a:solidFill>
+                <a:hlinkClick r:id="rId1" invalidUrl="" action="" tgtFrame="" tooltip="" history="1" highlightClick="0" endSnd="0">
+                  <a:extLst>
+                    <a:ext uri="{A12FA001-AC4F-418D-AE19-62706E023703}">
+                      <ahyp:hlinkClr xmlns:ahyp="http://schemas.microsoft.com/office/drawing/2018/hyperlinkcolor" val="tx"/>
+                    </a:ext>
+                  </a:extLst>
+                </a:hlinkClick>
+              </a:rPr>
+              <a:t>   ·   All videos on Google Drive</a:t>
+            </a:r>
             <a:endParaRPr lang="en-US" sz="1100" dirty="0"/>
           </a:p>
         </p:txBody>
@@ -10436,7 +10520,9 @@
       </p:sp>
       <p:pic>
         <p:nvPicPr>
-          <p:cNvPr id="3" name="video-wheels_real" descr="/tmp/claude-1000/-home-yifan-IsaacLab/02e1a1d7-61f9-5921-a435-b68e19ec6560/scratchpad/deck/img/vid/wheels_real.jpg">    </p:cNvPr>
+          <p:cNvPr id="3" name="video-wheels_real" descr="/tmp/claude-1000/-home-yifan-IsaacLab/02e1a1d7-61f9-5921-a435-b68e19ec6560/scratchpad/deck/img/vid/wheels_real.jpg">
+            <a:hlinkClick r:id="rId2" tooltip="Open video on Google Drive"/>
+          </p:cNvPr>
           <p:cNvPicPr>
             <a:picLocks noChangeAspect="1"/>
           </p:cNvPicPr>
@@ -10460,7 +10546,9 @@
       </p:pic>
       <p:sp>
         <p:nvSpPr>
-          <p:cNvPr id="4" name="Shape 1"/>
+          <p:cNvPr id="4" name="Shape 1">
+            <a:hlinkClick r:id="rId3" tooltip=""/>
+          </p:cNvPr>
           <p:cNvSpPr/>
           <p:nvPr/>
         </p:nvSpPr>
@@ -10544,12 +10632,19 @@
               <a:buNone/>
             </a:pPr>
             <a:r>
-              <a:rPr lang="en-US" sz="1200" i="1" dirty="0">
-                <a:solidFill>
-                  <a:schemeClr val="accent6"/>
-                </a:solidFill>
-              </a:rPr>
-              <a:t>Google Drive link: to be added (3 s)</a:t>
+              <a:rPr lang="en-US" sz="1200" u="sng" dirty="0">
+                <a:solidFill>
+                  <a:schemeClr val="accent4"/>
+                </a:solidFill>
+                <a:hlinkClick r:id="rId4" invalidUrl="" action="" tgtFrame="" tooltip="" history="1" highlightClick="0" endSnd="0">
+                  <a:extLst>
+                    <a:ext uri="{A12FA001-AC4F-418D-AE19-62706E023703}">
+                      <ahyp:hlinkClr xmlns:ahyp="http://schemas.microsoft.com/office/drawing/2018/hyperlinkcolor" val="tx"/>
+                    </a:ext>
+                  </a:extLst>
+                </a:hlinkClick>
+              </a:rPr>
+              <a:t>▶ Watch on Google Drive (3 s)</a:t>
             </a:r>
             <a:endParaRPr lang="en-US" sz="1200" dirty="0"/>
           </a:p>
@@ -10557,14 +10652,16 @@
       </p:sp>
       <p:pic>
         <p:nvPicPr>
-          <p:cNvPr id="7" name="video-wheels_slow" descr="/tmp/claude-1000/-home-yifan-IsaacLab/02e1a1d7-61f9-5921-a435-b68e19ec6560/scratchpad/deck/img/vid/wheels_slow.jpg">    </p:cNvPr>
+          <p:cNvPr id="7" name="video-wheels_slow" descr="/tmp/claude-1000/-home-yifan-IsaacLab/02e1a1d7-61f9-5921-a435-b68e19ec6560/scratchpad/deck/img/vid/wheels_slow.jpg">
+            <a:hlinkClick r:id="rId6" tooltip="Open video on Google Drive"/>
+          </p:cNvPr>
           <p:cNvPicPr>
             <a:picLocks noChangeAspect="1"/>
           </p:cNvPicPr>
           <p:nvPr/>
         </p:nvPicPr>
         <p:blipFill>
-          <a:blip r:embed="rId2"/>
+          <a:blip r:embed="rId5"/>
           <a:stretch>
             <a:fillRect/>
           </a:stretch>
@@ -10581,7 +10678,9 @@
       </p:pic>
       <p:sp>
         <p:nvSpPr>
-          <p:cNvPr id="8" name="Shape 4"/>
+          <p:cNvPr id="8" name="Shape 4">
+            <a:hlinkClick r:id="rId7" tooltip=""/>
+          </p:cNvPr>
           <p:cNvSpPr/>
           <p:nvPr/>
         </p:nvSpPr>
@@ -10665,12 +10764,19 @@
               <a:buNone/>
             </a:pPr>
             <a:r>
-              <a:rPr lang="en-US" sz="1200" i="1" dirty="0">
-                <a:solidFill>
-                  <a:schemeClr val="accent6"/>
-                </a:solidFill>
-              </a:rPr>
-              <a:t>Google Drive link: to be added (12 s)</a:t>
+              <a:rPr lang="en-US" sz="1200" u="sng" dirty="0">
+                <a:solidFill>
+                  <a:schemeClr val="accent4"/>
+                </a:solidFill>
+                <a:hlinkClick r:id="rId8" invalidUrl="" action="" tgtFrame="" tooltip="" history="1" highlightClick="0" endSnd="0">
+                  <a:extLst>
+                    <a:ext uri="{A12FA001-AC4F-418D-AE19-62706E023703}">
+                      <ahyp:hlinkClr xmlns:ahyp="http://schemas.microsoft.com/office/drawing/2018/hyperlinkcolor" val="tx"/>
+                    </a:ext>
+                  </a:extLst>
+                </a:hlinkClick>
+              </a:rPr>
+              <a:t>▶ Watch on Google Drive (12 s)</a:t>
             </a:r>
             <a:endParaRPr lang="en-US" sz="1200" dirty="0"/>
           </a:p>
@@ -10678,14 +10784,16 @@
       </p:sp>
       <p:pic>
         <p:nvPicPr>
-          <p:cNvPr id="11" name="video-wheels_anim" descr="/tmp/claude-1000/-home-yifan-IsaacLab/02e1a1d7-61f9-5921-a435-b68e19ec6560/scratchpad/deck/img/vid/wheels_anim.jpg">    </p:cNvPr>
+          <p:cNvPr id="11" name="video-wheels_anim" descr="/tmp/claude-1000/-home-yifan-IsaacLab/02e1a1d7-61f9-5921-a435-b68e19ec6560/scratchpad/deck/img/vid/wheels_anim.jpg">
+            <a:hlinkClick r:id="rId10" tooltip="Open video on Google Drive"/>
+          </p:cNvPr>
           <p:cNvPicPr>
             <a:picLocks noChangeAspect="1"/>
           </p:cNvPicPr>
           <p:nvPr/>
         </p:nvPicPr>
         <p:blipFill>
-          <a:blip r:embed="rId3"/>
+          <a:blip r:embed="rId9"/>
           <a:stretch>
             <a:fillRect/>
           </a:stretch>
@@ -10702,7 +10810,9 @@
       </p:pic>
       <p:sp>
         <p:nvSpPr>
-          <p:cNvPr id="12" name="Shape 7"/>
+          <p:cNvPr id="12" name="Shape 7">
+            <a:hlinkClick r:id="rId11" tooltip=""/>
+          </p:cNvPr>
           <p:cNvSpPr/>
           <p:nvPr/>
         </p:nvSpPr>
@@ -10786,12 +10896,19 @@
               <a:buNone/>
             </a:pPr>
             <a:r>
-              <a:rPr lang="en-US" sz="1200" i="1" dirty="0">
-                <a:solidFill>
-                  <a:schemeClr val="accent6"/>
-                </a:solidFill>
-              </a:rPr>
-              <a:t>Google Drive link: to be added (6 s)</a:t>
+              <a:rPr lang="en-US" sz="1200" u="sng" dirty="0">
+                <a:solidFill>
+                  <a:schemeClr val="accent4"/>
+                </a:solidFill>
+                <a:hlinkClick r:id="rId12" invalidUrl="" action="" tgtFrame="" tooltip="" history="1" highlightClick="0" endSnd="0">
+                  <a:extLst>
+                    <a:ext uri="{A12FA001-AC4F-418D-AE19-62706E023703}">
+                      <ahyp:hlinkClr xmlns:ahyp="http://schemas.microsoft.com/office/drawing/2018/hyperlinkcolor" val="tx"/>
+                    </a:ext>
+                  </a:extLst>
+                </a:hlinkClick>
+              </a:rPr>
+              <a:t>▶ Watch on Google Drive (6 s)</a:t>
             </a:r>
             <a:endParaRPr lang="en-US" sz="1200" dirty="0"/>
           </a:p>
@@ -16360,7 +16477,9 @@
       </p:sp>
       <p:pic>
         <p:nvPicPr>
-          <p:cNvPr id="3" name="video-soft_slow" descr="/tmp/claude-1000/-home-yifan-IsaacLab/02e1a1d7-61f9-5921-a435-b68e19ec6560/scratchpad/deck/img/vid/soft_slow.jpg">    </p:cNvPr>
+          <p:cNvPr id="3" name="video-soft_slow" descr="/tmp/claude-1000/-home-yifan-IsaacLab/02e1a1d7-61f9-5921-a435-b68e19ec6560/scratchpad/deck/img/vid/soft_slow.jpg">
+            <a:hlinkClick r:id="rId2" tooltip="Open video on Google Drive"/>
+          </p:cNvPr>
           <p:cNvPicPr>
             <a:picLocks noChangeAspect="1"/>
           </p:cNvPicPr>
@@ -16384,7 +16503,9 @@
       </p:pic>
       <p:sp>
         <p:nvSpPr>
-          <p:cNvPr id="4" name="Shape 1"/>
+          <p:cNvPr id="4" name="Shape 1">
+            <a:hlinkClick r:id="rId3" tooltip=""/>
+          </p:cNvPr>
           <p:cNvSpPr/>
           <p:nvPr/>
         </p:nvSpPr>
@@ -16468,12 +16589,19 @@
               <a:buNone/>
             </a:pPr>
             <a:r>
-              <a:rPr lang="en-US" sz="1200" i="1" dirty="0">
-                <a:solidFill>
-                  <a:schemeClr val="accent6"/>
-                </a:solidFill>
-              </a:rPr>
-              <a:t>Google Drive link: to be added (12 s, 4× slow)</a:t>
+              <a:rPr lang="en-US" sz="1200" u="sng" dirty="0">
+                <a:solidFill>
+                  <a:schemeClr val="accent4"/>
+                </a:solidFill>
+                <a:hlinkClick r:id="rId4" invalidUrl="" action="" tgtFrame="" tooltip="" history="1" highlightClick="0" endSnd="0">
+                  <a:extLst>
+                    <a:ext uri="{A12FA001-AC4F-418D-AE19-62706E023703}">
+                      <ahyp:hlinkClr xmlns:ahyp="http://schemas.microsoft.com/office/drawing/2018/hyperlinkcolor" val="tx"/>
+                    </a:ext>
+                  </a:extLst>
+                </a:hlinkClick>
+              </a:rPr>
+              <a:t>▶ Watch on Google Drive (12 s, 4× slow)</a:t>
             </a:r>
             <a:endParaRPr lang="en-US" sz="1200" dirty="0"/>
           </a:p>
@@ -16481,14 +16609,16 @@
       </p:sp>
       <p:pic>
         <p:nvPicPr>
-          <p:cNvPr id="7" name="video-mit_slow" descr="/tmp/claude-1000/-home-yifan-IsaacLab/02e1a1d7-61f9-5921-a435-b68e19ec6560/scratchpad/deck/img/vid/mit_slow.jpg">    </p:cNvPr>
+          <p:cNvPr id="7" name="video-mit_slow" descr="/tmp/claude-1000/-home-yifan-IsaacLab/02e1a1d7-61f9-5921-a435-b68e19ec6560/scratchpad/deck/img/vid/mit_slow.jpg">
+            <a:hlinkClick r:id="rId6" tooltip="Open video on Google Drive"/>
+          </p:cNvPr>
           <p:cNvPicPr>
             <a:picLocks noChangeAspect="1"/>
           </p:cNvPicPr>
           <p:nvPr/>
         </p:nvPicPr>
         <p:blipFill>
-          <a:blip r:embed="rId2"/>
+          <a:blip r:embed="rId5"/>
           <a:stretch>
             <a:fillRect/>
           </a:stretch>
@@ -16505,7 +16635,9 @@
       </p:pic>
       <p:sp>
         <p:nvSpPr>
-          <p:cNvPr id="8" name="Shape 4"/>
+          <p:cNvPr id="8" name="Shape 4">
+            <a:hlinkClick r:id="rId7" tooltip=""/>
+          </p:cNvPr>
           <p:cNvSpPr/>
           <p:nvPr/>
         </p:nvSpPr>
@@ -16589,12 +16721,19 @@
               <a:buNone/>
             </a:pPr>
             <a:r>
-              <a:rPr lang="en-US" sz="1200" i="1" dirty="0">
-                <a:solidFill>
-                  <a:schemeClr val="accent6"/>
-                </a:solidFill>
-              </a:rPr>
-              <a:t>Google Drive link: to be added (12 s, 4× slow)</a:t>
+              <a:rPr lang="en-US" sz="1200" u="sng" dirty="0">
+                <a:solidFill>
+                  <a:schemeClr val="accent4"/>
+                </a:solidFill>
+                <a:hlinkClick r:id="rId8" invalidUrl="" action="" tgtFrame="" tooltip="" history="1" highlightClick="0" endSnd="0">
+                  <a:extLst>
+                    <a:ext uri="{A12FA001-AC4F-418D-AE19-62706E023703}">
+                      <ahyp:hlinkClr xmlns:ahyp="http://schemas.microsoft.com/office/drawing/2018/hyperlinkcolor" val="tx"/>
+                    </a:ext>
+                  </a:extLst>
+                </a:hlinkClick>
+              </a:rPr>
+              <a:t>▶ Watch on Google Drive (12 s, 4× slow)</a:t>
             </a:r>
             <a:endParaRPr lang="en-US" sz="1200" dirty="0"/>
           </a:p>
@@ -16602,14 +16741,16 @@
       </p:sp>
       <p:pic>
         <p:nvPicPr>
-          <p:cNvPr id="11" name="video-robust_slow" descr="/tmp/claude-1000/-home-yifan-IsaacLab/02e1a1d7-61f9-5921-a435-b68e19ec6560/scratchpad/deck/img/vid/robust_slow.jpg">    </p:cNvPr>
+          <p:cNvPr id="11" name="video-robust_slow" descr="/tmp/claude-1000/-home-yifan-IsaacLab/02e1a1d7-61f9-5921-a435-b68e19ec6560/scratchpad/deck/img/vid/robust_slow.jpg">
+            <a:hlinkClick r:id="rId10" tooltip="Open video on Google Drive"/>
+          </p:cNvPr>
           <p:cNvPicPr>
             <a:picLocks noChangeAspect="1"/>
           </p:cNvPicPr>
           <p:nvPr/>
         </p:nvPicPr>
         <p:blipFill>
-          <a:blip r:embed="rId3"/>
+          <a:blip r:embed="rId9"/>
           <a:stretch>
             <a:fillRect/>
           </a:stretch>
@@ -16626,7 +16767,9 @@
       </p:pic>
       <p:sp>
         <p:nvSpPr>
-          <p:cNvPr id="12" name="Shape 7"/>
+          <p:cNvPr id="12" name="Shape 7">
+            <a:hlinkClick r:id="rId11" tooltip=""/>
+          </p:cNvPr>
           <p:cNvSpPr/>
           <p:nvPr/>
         </p:nvSpPr>
@@ -16710,12 +16853,19 @@
               <a:buNone/>
             </a:pPr>
             <a:r>
-              <a:rPr lang="en-US" sz="1200" i="1" dirty="0">
-                <a:solidFill>
-                  <a:schemeClr val="accent6"/>
-                </a:solidFill>
-              </a:rPr>
-              <a:t>Google Drive link: to be added (12 s, 4× slow)</a:t>
+              <a:rPr lang="en-US" sz="1200" u="sng" dirty="0">
+                <a:solidFill>
+                  <a:schemeClr val="accent4"/>
+                </a:solidFill>
+                <a:hlinkClick r:id="rId12" invalidUrl="" action="" tgtFrame="" tooltip="" history="1" highlightClick="0" endSnd="0">
+                  <a:extLst>
+                    <a:ext uri="{A12FA001-AC4F-418D-AE19-62706E023703}">
+                      <ahyp:hlinkClr xmlns:ahyp="http://schemas.microsoft.com/office/drawing/2018/hyperlinkcolor" val="tx"/>
+                    </a:ext>
+                  </a:extLst>
+                </a:hlinkClick>
+              </a:rPr>
+              <a:t>▶ Watch on Google Drive (12 s, 4× slow)</a:t>
             </a:r>
             <a:endParaRPr lang="en-US" sz="1200" dirty="0"/>
           </a:p>
@@ -16723,14 +16873,16 @@
       </p:sp>
       <p:pic>
         <p:nvPicPr>
-          <p:cNvPr id="15" name="video-wheels_slow" descr="/tmp/claude-1000/-home-yifan-IsaacLab/02e1a1d7-61f9-5921-a435-b68e19ec6560/scratchpad/deck/img/vid/wheels_slow.jpg">    </p:cNvPr>
+          <p:cNvPr id="15" name="video-wheels_slow" descr="/tmp/claude-1000/-home-yifan-IsaacLab/02e1a1d7-61f9-5921-a435-b68e19ec6560/scratchpad/deck/img/vid/wheels_slow.jpg">
+            <a:hlinkClick r:id="rId14" tooltip="Open video on Google Drive"/>
+          </p:cNvPr>
           <p:cNvPicPr>
             <a:picLocks noChangeAspect="1"/>
           </p:cNvPicPr>
           <p:nvPr/>
         </p:nvPicPr>
         <p:blipFill>
-          <a:blip r:embed="rId4"/>
+          <a:blip r:embed="rId13"/>
           <a:stretch>
             <a:fillRect/>
           </a:stretch>
@@ -16747,7 +16899,9 @@
       </p:pic>
       <p:sp>
         <p:nvSpPr>
-          <p:cNvPr id="16" name="Shape 10"/>
+          <p:cNvPr id="16" name="Shape 10">
+            <a:hlinkClick r:id="rId15" tooltip=""/>
+          </p:cNvPr>
           <p:cNvSpPr/>
           <p:nvPr/>
         </p:nvSpPr>
@@ -16831,12 +16985,19 @@
               <a:buNone/>
             </a:pPr>
             <a:r>
-              <a:rPr lang="en-US" sz="1200" i="1" dirty="0">
-                <a:solidFill>
-                  <a:schemeClr val="accent6"/>
-                </a:solidFill>
-              </a:rPr>
-              <a:t>Google Drive link: to be added (12 s, 4× slow)</a:t>
+              <a:rPr lang="en-US" sz="1200" u="sng" dirty="0">
+                <a:solidFill>
+                  <a:schemeClr val="accent4"/>
+                </a:solidFill>
+                <a:hlinkClick r:id="rId16" invalidUrl="" action="" tgtFrame="" tooltip="" history="1" highlightClick="0" endSnd="0">
+                  <a:extLst>
+                    <a:ext uri="{A12FA001-AC4F-418D-AE19-62706E023703}">
+                      <ahyp:hlinkClr xmlns:ahyp="http://schemas.microsoft.com/office/drawing/2018/hyperlinkcolor" val="tx"/>
+                    </a:ext>
+                  </a:extLst>
+                </a:hlinkClick>
+              </a:rPr>
+              <a:t>▶ Watch on Google Drive (12 s, 4× slow)</a:t>
             </a:r>
             <a:endParaRPr lang="en-US" sz="1200" dirty="0"/>
           </a:p>

</xml_diff>